<commit_message>
Plaquette paysage: page 'Our story' (Mustang Oil Services, 2013-2025) et texte About us mis à jour
Co-Authored-By: Claude Sonnet 5.5 <noreply@anthropic.com>
Claude-Session: https://claude.ai/code/session_01XPwnZBmWUGhvYebrP3X3Z2
</commit_message>
<xml_diff>
--- a/Plaquette_Enedril_6p_paysage.pptx
+++ b/Plaquette_Enedril_6p_paysage.pptx
@@ -11,6 +11,7 @@
     <p:sldId id="259" r:id="rId10"/>
     <p:sldId id="260" r:id="rId11"/>
     <p:sldId id="261" r:id="rId12"/>
+    <p:sldId id="262" r:id="rId13"/>
   </p:sldIdLst>
   <p:sldSz cx="10693400" cy="7556500" type="screen4x3"/>
   <p:notesSz cx="6858000" cy="9144000"/>
@@ -3714,7 +3715,7 @@
                 <a:cs typeface="Ubuntu Mono"/>
                 <a:sym typeface="Ubuntu Mono"/>
               </a:rPr>
-              <a:t>Enedril (formerly Mustang Services) is an independent French company founded in 2013, specialised in directional drilling, fishing and well intervention for geothermal, oil &amp; gas and underground gas storage projects, in France and abroad. We combine field experience with technical know-how, and we are known for being fast, flexible and easy to work with.</a:t>
+              <a:t>Enedril (formerly Mustang Oil Services) is an independent French company founded in 2013, specialised in directional drilling, fishing and well intervention for geothermal, oil &amp; gas and underground gas storage projects, in France and abroad. Run since 2022 by Fabien and Alexis, it combines field experience with technical know-how, and is known for being fast, flexible and easy to work with.</a:t>
             </a:r>
           </a:p>
         </p:txBody>
@@ -3727,7 +3728,7 @@
         </p:nvSpPr>
         <p:spPr>
           <a:xfrm>
-            <a:off x="457200" y="2311400"/>
+            <a:off x="457200" y="2463800"/>
             <a:ext cx="2997200" cy="127000"/>
           </a:xfrm>
           <a:prstGeom prst="rect">
@@ -3769,7 +3770,7 @@
         </p:nvSpPr>
         <p:spPr>
           <a:xfrm>
-            <a:off x="457200" y="2527300"/>
+            <a:off x="457200" y="2679700"/>
             <a:ext cx="2997200" cy="127000"/>
           </a:xfrm>
           <a:prstGeom prst="rect">
@@ -5486,6 +5487,1447 @@
 </file>
 
 <file path=ppt/slides/slide3.xml><?xml version="1.0" encoding="utf-8"?>
+<p:sld xmlns:a="http://schemas.openxmlformats.org/drawingml/2006/main" xmlns:p="http://schemas.openxmlformats.org/presentationml/2006/main" xmlns:r="http://schemas.openxmlformats.org/officeDocument/2006/relationships">
+  <p:cSld>
+    <p:spTree>
+      <p:nvGrpSpPr>
+        <p:cNvPr id="1" name=""/>
+        <p:cNvGrpSpPr/>
+        <p:nvPr/>
+      </p:nvGrpSpPr>
+      <p:grpSpPr/>
+      <p:pic>
+        <p:nvPicPr>
+          <p:cNvPr id="2" name="Picture 1" descr="logo.png"/>
+          <p:cNvPicPr>
+            <a:picLocks noChangeAspect="1"/>
+          </p:cNvPicPr>
+          <p:nvPr/>
+        </p:nvPicPr>
+        <p:blipFill>
+          <a:blip r:embed="rId2"/>
+          <a:stretch>
+            <a:fillRect/>
+          </a:stretch>
+        </p:blipFill>
+        <p:spPr>
+          <a:xfrm>
+            <a:off x="8737600" y="228600"/>
+            <a:ext cx="1498600" cy="336115"/>
+          </a:xfrm>
+          <a:prstGeom prst="rect">
+            <a:avLst/>
+          </a:prstGeom>
+        </p:spPr>
+      </p:pic>
+      <p:sp>
+        <p:nvSpPr>
+          <p:cNvPr id="3" name="TextBox 2"/>
+          <p:cNvSpPr txBox="1"/>
+          <p:nvPr/>
+        </p:nvSpPr>
+        <p:spPr>
+          <a:xfrm>
+            <a:off x="457200" y="457200"/>
+            <a:ext cx="8128000" cy="127000"/>
+          </a:xfrm>
+          <a:prstGeom prst="rect">
+            <a:avLst/>
+          </a:prstGeom>
+          <a:noFill/>
+        </p:spPr>
+        <p:txBody>
+          <a:bodyPr wrap="square" lIns="0" rIns="0" tIns="0" bIns="0" anchor="t">
+            <a:spAutoFit/>
+          </a:bodyPr>
+          <a:lstStyle/>
+          <a:p>
+            <a:pPr algn="l">
+              <a:lnSpc>
+                <a:spcPts val="2900"/>
+              </a:lnSpc>
+              <a:spcAft>
+                <a:spcPts val="0"/>
+              </a:spcAft>
+            </a:pPr>
+            <a:r>
+              <a:rPr sz="2600" b="1" i="0">
+                <a:solidFill>
+                  <a:srgbClr val="1CB2FE"/>
+                </a:solidFill>
+                <a:latin typeface="Ubuntu Mono"/>
+                <a:ea typeface="Ubuntu Mono"/>
+                <a:cs typeface="Ubuntu Mono"/>
+                <a:sym typeface="Ubuntu Mono"/>
+              </a:rPr>
+              <a:t>OUR STORY</a:t>
+            </a:r>
+          </a:p>
+        </p:txBody>
+      </p:sp>
+      <p:sp>
+        <p:nvSpPr>
+          <p:cNvPr id="4" name="Rectangle 3"/>
+          <p:cNvSpPr/>
+          <p:nvPr/>
+        </p:nvSpPr>
+        <p:spPr>
+          <a:xfrm>
+            <a:off x="457200" y="1143000"/>
+            <a:ext cx="44450" cy="431800"/>
+          </a:xfrm>
+          <a:prstGeom prst="rect">
+            <a:avLst/>
+          </a:prstGeom>
+          <a:solidFill>
+            <a:srgbClr val="0F7FCB"/>
+          </a:solidFill>
+          <a:ln>
+            <a:noFill/>
+          </a:ln>
+        </p:spPr>
+        <p:txBody>
+          <a:bodyPr rtlCol="0" anchor="ctr"/>
+          <a:lstStyle/>
+          <a:p>
+            <a:pPr algn="ctr"/>
+          </a:p>
+        </p:txBody>
+      </p:sp>
+      <p:sp>
+        <p:nvSpPr>
+          <p:cNvPr id="5" name="TextBox 4"/>
+          <p:cNvSpPr txBox="1"/>
+          <p:nvPr/>
+        </p:nvSpPr>
+        <p:spPr>
+          <a:xfrm>
+            <a:off x="635000" y="1143000"/>
+            <a:ext cx="8128000" cy="127000"/>
+          </a:xfrm>
+          <a:prstGeom prst="rect">
+            <a:avLst/>
+          </a:prstGeom>
+          <a:noFill/>
+        </p:spPr>
+        <p:txBody>
+          <a:bodyPr wrap="square" lIns="0" rIns="0" tIns="0" bIns="0" anchor="t">
+            <a:spAutoFit/>
+          </a:bodyPr>
+          <a:lstStyle/>
+          <a:p>
+            <a:pPr algn="l">
+              <a:lnSpc>
+                <a:spcPts val="1400"/>
+              </a:lnSpc>
+              <a:spcAft>
+                <a:spcPts val="0"/>
+              </a:spcAft>
+            </a:pPr>
+            <a:r>
+              <a:rPr sz="1100" b="1" i="0">
+                <a:solidFill>
+                  <a:srgbClr val="194E9A"/>
+                </a:solidFill>
+                <a:latin typeface="Ubuntu Mono"/>
+                <a:ea typeface="Ubuntu Mono"/>
+                <a:cs typeface="Ubuntu Mono"/>
+                <a:sym typeface="Ubuntu Mono"/>
+              </a:rPr>
+              <a:t>From Mustang Oil Services to Enedril: a company with a history, and a new dynamic.</a:t>
+            </a:r>
+          </a:p>
+        </p:txBody>
+      </p:sp>
+      <p:sp>
+        <p:nvSpPr>
+          <p:cNvPr id="6" name="Rectangle 5"/>
+          <p:cNvSpPr/>
+          <p:nvPr/>
+        </p:nvSpPr>
+        <p:spPr>
+          <a:xfrm>
+            <a:off x="457200" y="2209800"/>
+            <a:ext cx="9779000" cy="38100"/>
+          </a:xfrm>
+          <a:prstGeom prst="rect">
+            <a:avLst/>
+          </a:prstGeom>
+          <a:solidFill>
+            <a:srgbClr val="B9CCE0"/>
+          </a:solidFill>
+          <a:ln>
+            <a:noFill/>
+          </a:ln>
+        </p:spPr>
+        <p:txBody>
+          <a:bodyPr rtlCol="0" anchor="ctr"/>
+          <a:lstStyle/>
+          <a:p>
+            <a:pPr algn="ctr"/>
+          </a:p>
+        </p:txBody>
+      </p:sp>
+      <p:sp>
+        <p:nvSpPr>
+          <p:cNvPr id="7" name="Rectangle 6"/>
+          <p:cNvSpPr/>
+          <p:nvPr/>
+        </p:nvSpPr>
+        <p:spPr>
+          <a:xfrm>
+            <a:off x="457200" y="1524000"/>
+            <a:ext cx="2260600" cy="584200"/>
+          </a:xfrm>
+          <a:prstGeom prst="rect">
+            <a:avLst/>
+          </a:prstGeom>
+          <a:solidFill>
+            <a:srgbClr val="194E9A"/>
+          </a:solidFill>
+          <a:ln>
+            <a:noFill/>
+          </a:ln>
+        </p:spPr>
+        <p:txBody>
+          <a:bodyPr rtlCol="0" anchor="ctr"/>
+          <a:lstStyle/>
+          <a:p>
+            <a:pPr algn="ctr"/>
+          </a:p>
+        </p:txBody>
+      </p:sp>
+      <p:sp>
+        <p:nvSpPr>
+          <p:cNvPr id="8" name="TextBox 7"/>
+          <p:cNvSpPr txBox="1"/>
+          <p:nvPr/>
+        </p:nvSpPr>
+        <p:spPr>
+          <a:xfrm>
+            <a:off x="457200" y="1617472"/>
+            <a:ext cx="2260600" cy="127000"/>
+          </a:xfrm>
+          <a:prstGeom prst="rect">
+            <a:avLst/>
+          </a:prstGeom>
+          <a:noFill/>
+        </p:spPr>
+        <p:txBody>
+          <a:bodyPr wrap="square" lIns="0" rIns="0" tIns="0" bIns="0" anchor="t">
+            <a:spAutoFit/>
+          </a:bodyPr>
+          <a:lstStyle/>
+          <a:p>
+            <a:pPr algn="ctr">
+              <a:lnSpc>
+                <a:spcPts val="2700"/>
+              </a:lnSpc>
+              <a:spcAft>
+                <a:spcPts val="0"/>
+              </a:spcAft>
+            </a:pPr>
+            <a:r>
+              <a:rPr sz="2400" b="1" i="0">
+                <a:solidFill>
+                  <a:srgbClr val="FFFFFF"/>
+                </a:solidFill>
+                <a:latin typeface="Ubuntu Mono"/>
+                <a:ea typeface="Ubuntu Mono"/>
+                <a:cs typeface="Ubuntu Mono"/>
+                <a:sym typeface="Ubuntu Mono"/>
+              </a:rPr>
+              <a:t>2013</a:t>
+            </a:r>
+          </a:p>
+        </p:txBody>
+      </p:sp>
+      <p:sp>
+        <p:nvSpPr>
+          <p:cNvPr id="9" name="TextBox 8"/>
+          <p:cNvSpPr txBox="1"/>
+          <p:nvPr/>
+        </p:nvSpPr>
+        <p:spPr>
+          <a:xfrm>
+            <a:off x="533400" y="1985772"/>
+            <a:ext cx="2108200" cy="127000"/>
+          </a:xfrm>
+          <a:prstGeom prst="rect">
+            <a:avLst/>
+          </a:prstGeom>
+          <a:noFill/>
+        </p:spPr>
+        <p:txBody>
+          <a:bodyPr wrap="square" lIns="0" rIns="0" tIns="0" bIns="0" anchor="t">
+            <a:spAutoFit/>
+          </a:bodyPr>
+          <a:lstStyle/>
+          <a:p>
+            <a:pPr algn="ctr">
+              <a:lnSpc>
+                <a:spcPts val="840"/>
+              </a:lnSpc>
+              <a:spcAft>
+                <a:spcPts val="0"/>
+              </a:spcAft>
+            </a:pPr>
+            <a:r>
+              <a:rPr sz="690" b="0" i="0">
+                <a:solidFill>
+                  <a:srgbClr val="FFFFFF"/>
+                </a:solidFill>
+                <a:latin typeface="Ubuntu Mono"/>
+                <a:ea typeface="Ubuntu Mono"/>
+                <a:cs typeface="Ubuntu Mono"/>
+                <a:sym typeface="Ubuntu Mono"/>
+              </a:rPr>
+              <a:t/>
+            </a:r>
+          </a:p>
+        </p:txBody>
+      </p:sp>
+      <p:sp>
+        <p:nvSpPr>
+          <p:cNvPr id="10" name="Rectangle 9"/>
+          <p:cNvSpPr/>
+          <p:nvPr/>
+        </p:nvSpPr>
+        <p:spPr>
+          <a:xfrm>
+            <a:off x="1536700" y="2133600"/>
+            <a:ext cx="101600" cy="177800"/>
+          </a:xfrm>
+          <a:prstGeom prst="rect">
+            <a:avLst/>
+          </a:prstGeom>
+          <a:solidFill>
+            <a:srgbClr val="194E9A"/>
+          </a:solidFill>
+          <a:ln>
+            <a:noFill/>
+          </a:ln>
+        </p:spPr>
+        <p:txBody>
+          <a:bodyPr rtlCol="0" anchor="ctr"/>
+          <a:lstStyle/>
+          <a:p>
+            <a:pPr algn="ctr"/>
+          </a:p>
+        </p:txBody>
+      </p:sp>
+      <p:sp>
+        <p:nvSpPr>
+          <p:cNvPr id="11" name="TextBox 10"/>
+          <p:cNvSpPr txBox="1"/>
+          <p:nvPr/>
+        </p:nvSpPr>
+        <p:spPr>
+          <a:xfrm>
+            <a:off x="457200" y="2489200"/>
+            <a:ext cx="2260600" cy="127000"/>
+          </a:xfrm>
+          <a:prstGeom prst="rect">
+            <a:avLst/>
+          </a:prstGeom>
+          <a:noFill/>
+        </p:spPr>
+        <p:txBody>
+          <a:bodyPr wrap="square" lIns="0" rIns="0" tIns="0" bIns="0" anchor="t">
+            <a:spAutoFit/>
+          </a:bodyPr>
+          <a:lstStyle/>
+          <a:p>
+            <a:pPr algn="l">
+              <a:lnSpc>
+                <a:spcPts val="1050"/>
+              </a:lnSpc>
+              <a:spcAft>
+                <a:spcPts val="400"/>
+              </a:spcAft>
+            </a:pPr>
+            <a:r>
+              <a:rPr sz="880" b="1" i="0">
+                <a:solidFill>
+                  <a:srgbClr val="194E9A"/>
+                </a:solidFill>
+                <a:latin typeface="Ubuntu Mono"/>
+                <a:ea typeface="Ubuntu Mono"/>
+                <a:cs typeface="Ubuntu Mono"/>
+                <a:sym typeface="Ubuntu Mono"/>
+              </a:rPr>
+              <a:t>MUSTANG OIL SERVICES</a:t>
+            </a:r>
+          </a:p>
+          <a:p>
+            <a:pPr algn="l">
+              <a:lnSpc>
+                <a:spcPts val="1050"/>
+              </a:lnSpc>
+              <a:spcAft>
+                <a:spcPts val="400"/>
+              </a:spcAft>
+            </a:pPr>
+            <a:r>
+              <a:rPr sz="760" b="0" i="0">
+                <a:solidFill>
+                  <a:srgbClr val="0B1B2E"/>
+                </a:solidFill>
+                <a:latin typeface="Ubuntu Mono"/>
+                <a:ea typeface="Ubuntu Mono"/>
+                <a:cs typeface="Ubuntu Mono"/>
+                <a:sym typeface="Ubuntu Mono"/>
+              </a:rPr>
+              <a:t>The company starts as Mustang Oil Services, dedicated to fishing only.</a:t>
+            </a:r>
+          </a:p>
+        </p:txBody>
+      </p:sp>
+      <p:sp>
+        <p:nvSpPr>
+          <p:cNvPr id="12" name="Rectangle 11"/>
+          <p:cNvSpPr/>
+          <p:nvPr/>
+        </p:nvSpPr>
+        <p:spPr>
+          <a:xfrm>
+            <a:off x="2946400" y="1524000"/>
+            <a:ext cx="2260600" cy="584200"/>
+          </a:xfrm>
+          <a:prstGeom prst="rect">
+            <a:avLst/>
+          </a:prstGeom>
+          <a:solidFill>
+            <a:srgbClr val="0F7FCB"/>
+          </a:solidFill>
+          <a:ln>
+            <a:noFill/>
+          </a:ln>
+        </p:spPr>
+        <p:txBody>
+          <a:bodyPr rtlCol="0" anchor="ctr"/>
+          <a:lstStyle/>
+          <a:p>
+            <a:pPr algn="ctr"/>
+          </a:p>
+        </p:txBody>
+      </p:sp>
+      <p:sp>
+        <p:nvSpPr>
+          <p:cNvPr id="13" name="TextBox 12"/>
+          <p:cNvSpPr txBox="1"/>
+          <p:nvPr/>
+        </p:nvSpPr>
+        <p:spPr>
+          <a:xfrm>
+            <a:off x="2946400" y="1617472"/>
+            <a:ext cx="2260600" cy="127000"/>
+          </a:xfrm>
+          <a:prstGeom prst="rect">
+            <a:avLst/>
+          </a:prstGeom>
+          <a:noFill/>
+        </p:spPr>
+        <p:txBody>
+          <a:bodyPr wrap="square" lIns="0" rIns="0" tIns="0" bIns="0" anchor="t">
+            <a:spAutoFit/>
+          </a:bodyPr>
+          <a:lstStyle/>
+          <a:p>
+            <a:pPr algn="ctr">
+              <a:lnSpc>
+                <a:spcPts val="2700"/>
+              </a:lnSpc>
+              <a:spcAft>
+                <a:spcPts val="0"/>
+              </a:spcAft>
+            </a:pPr>
+            <a:r>
+              <a:rPr sz="2400" b="1" i="0">
+                <a:solidFill>
+                  <a:srgbClr val="FFFFFF"/>
+                </a:solidFill>
+                <a:latin typeface="Ubuntu Mono"/>
+                <a:ea typeface="Ubuntu Mono"/>
+                <a:cs typeface="Ubuntu Mono"/>
+                <a:sym typeface="Ubuntu Mono"/>
+              </a:rPr>
+              <a:t>2019</a:t>
+            </a:r>
+          </a:p>
+        </p:txBody>
+      </p:sp>
+      <p:sp>
+        <p:nvSpPr>
+          <p:cNvPr id="14" name="TextBox 13"/>
+          <p:cNvSpPr txBox="1"/>
+          <p:nvPr/>
+        </p:nvSpPr>
+        <p:spPr>
+          <a:xfrm>
+            <a:off x="3022600" y="1985772"/>
+            <a:ext cx="2108200" cy="127000"/>
+          </a:xfrm>
+          <a:prstGeom prst="rect">
+            <a:avLst/>
+          </a:prstGeom>
+          <a:noFill/>
+        </p:spPr>
+        <p:txBody>
+          <a:bodyPr wrap="square" lIns="0" rIns="0" tIns="0" bIns="0" anchor="t">
+            <a:spAutoFit/>
+          </a:bodyPr>
+          <a:lstStyle/>
+          <a:p>
+            <a:pPr algn="ctr">
+              <a:lnSpc>
+                <a:spcPts val="840"/>
+              </a:lnSpc>
+              <a:spcAft>
+                <a:spcPts val="0"/>
+              </a:spcAft>
+            </a:pPr>
+            <a:r>
+              <a:rPr sz="690" b="0" i="0">
+                <a:solidFill>
+                  <a:srgbClr val="FFFFFF"/>
+                </a:solidFill>
+                <a:latin typeface="Ubuntu Mono"/>
+                <a:ea typeface="Ubuntu Mono"/>
+                <a:cs typeface="Ubuntu Mono"/>
+                <a:sym typeface="Ubuntu Mono"/>
+              </a:rPr>
+              <a:t/>
+            </a:r>
+          </a:p>
+        </p:txBody>
+      </p:sp>
+      <p:sp>
+        <p:nvSpPr>
+          <p:cNvPr id="15" name="Rectangle 14"/>
+          <p:cNvSpPr/>
+          <p:nvPr/>
+        </p:nvSpPr>
+        <p:spPr>
+          <a:xfrm>
+            <a:off x="4025900" y="2133600"/>
+            <a:ext cx="101600" cy="177800"/>
+          </a:xfrm>
+          <a:prstGeom prst="rect">
+            <a:avLst/>
+          </a:prstGeom>
+          <a:solidFill>
+            <a:srgbClr val="0F7FCB"/>
+          </a:solidFill>
+          <a:ln>
+            <a:noFill/>
+          </a:ln>
+        </p:spPr>
+        <p:txBody>
+          <a:bodyPr rtlCol="0" anchor="ctr"/>
+          <a:lstStyle/>
+          <a:p>
+            <a:pPr algn="ctr"/>
+          </a:p>
+        </p:txBody>
+      </p:sp>
+      <p:sp>
+        <p:nvSpPr>
+          <p:cNvPr id="16" name="TextBox 15"/>
+          <p:cNvSpPr txBox="1"/>
+          <p:nvPr/>
+        </p:nvSpPr>
+        <p:spPr>
+          <a:xfrm>
+            <a:off x="2946400" y="2489200"/>
+            <a:ext cx="2260600" cy="127000"/>
+          </a:xfrm>
+          <a:prstGeom prst="rect">
+            <a:avLst/>
+          </a:prstGeom>
+          <a:noFill/>
+        </p:spPr>
+        <p:txBody>
+          <a:bodyPr wrap="square" lIns="0" rIns="0" tIns="0" bIns="0" anchor="t">
+            <a:spAutoFit/>
+          </a:bodyPr>
+          <a:lstStyle/>
+          <a:p>
+            <a:pPr algn="l">
+              <a:lnSpc>
+                <a:spcPts val="1050"/>
+              </a:lnSpc>
+              <a:spcAft>
+                <a:spcPts val="400"/>
+              </a:spcAft>
+            </a:pPr>
+            <a:r>
+              <a:rPr sz="880" b="1" i="0">
+                <a:solidFill>
+                  <a:srgbClr val="194E9A"/>
+                </a:solidFill>
+                <a:latin typeface="Ubuntu Mono"/>
+                <a:ea typeface="Ubuntu Mono"/>
+                <a:cs typeface="Ubuntu Mono"/>
+                <a:sym typeface="Ubuntu Mono"/>
+              </a:rPr>
+              <a:t>DIRECTIONAL DRILLING + FISHING</a:t>
+            </a:r>
+          </a:p>
+          <a:p>
+            <a:pPr algn="l">
+              <a:lnSpc>
+                <a:spcPts val="1050"/>
+              </a:lnSpc>
+              <a:spcAft>
+                <a:spcPts val="400"/>
+              </a:spcAft>
+            </a:pPr>
+            <a:r>
+              <a:rPr sz="760" b="0" i="0">
+                <a:solidFill>
+                  <a:srgbClr val="0B1B2E"/>
+                </a:solidFill>
+                <a:latin typeface="Ubuntu Mono"/>
+                <a:ea typeface="Ubuntu Mono"/>
+                <a:cs typeface="Ubuntu Mono"/>
+                <a:sym typeface="Ubuntu Mono"/>
+              </a:rPr>
+              <a:t>Directional drilling joins fishing: the offer now covers drilling projects as well as interventions.</a:t>
+            </a:r>
+          </a:p>
+        </p:txBody>
+      </p:sp>
+      <p:sp>
+        <p:nvSpPr>
+          <p:cNvPr id="17" name="Rectangle 16"/>
+          <p:cNvSpPr/>
+          <p:nvPr/>
+        </p:nvSpPr>
+        <p:spPr>
+          <a:xfrm>
+            <a:off x="5435600" y="1524000"/>
+            <a:ext cx="2260600" cy="584200"/>
+          </a:xfrm>
+          <a:prstGeom prst="rect">
+            <a:avLst/>
+          </a:prstGeom>
+          <a:solidFill>
+            <a:srgbClr val="2BAEF6"/>
+          </a:solidFill>
+          <a:ln>
+            <a:noFill/>
+          </a:ln>
+        </p:spPr>
+        <p:txBody>
+          <a:bodyPr rtlCol="0" anchor="ctr"/>
+          <a:lstStyle/>
+          <a:p>
+            <a:pPr algn="ctr"/>
+          </a:p>
+        </p:txBody>
+      </p:sp>
+      <p:sp>
+        <p:nvSpPr>
+          <p:cNvPr id="18" name="TextBox 17"/>
+          <p:cNvSpPr txBox="1"/>
+          <p:nvPr/>
+        </p:nvSpPr>
+        <p:spPr>
+          <a:xfrm>
+            <a:off x="5435600" y="1617472"/>
+            <a:ext cx="2260600" cy="127000"/>
+          </a:xfrm>
+          <a:prstGeom prst="rect">
+            <a:avLst/>
+          </a:prstGeom>
+          <a:noFill/>
+        </p:spPr>
+        <p:txBody>
+          <a:bodyPr wrap="square" lIns="0" rIns="0" tIns="0" bIns="0" anchor="t">
+            <a:spAutoFit/>
+          </a:bodyPr>
+          <a:lstStyle/>
+          <a:p>
+            <a:pPr algn="ctr">
+              <a:lnSpc>
+                <a:spcPts val="2700"/>
+              </a:lnSpc>
+              <a:spcAft>
+                <a:spcPts val="0"/>
+              </a:spcAft>
+            </a:pPr>
+            <a:r>
+              <a:rPr sz="2400" b="1" i="0">
+                <a:solidFill>
+                  <a:srgbClr val="FFFFFF"/>
+                </a:solidFill>
+                <a:latin typeface="Ubuntu Mono"/>
+                <a:ea typeface="Ubuntu Mono"/>
+                <a:cs typeface="Ubuntu Mono"/>
+                <a:sym typeface="Ubuntu Mono"/>
+              </a:rPr>
+              <a:t>2022</a:t>
+            </a:r>
+          </a:p>
+        </p:txBody>
+      </p:sp>
+      <p:sp>
+        <p:nvSpPr>
+          <p:cNvPr id="19" name="TextBox 18"/>
+          <p:cNvSpPr txBox="1"/>
+          <p:nvPr/>
+        </p:nvSpPr>
+        <p:spPr>
+          <a:xfrm>
+            <a:off x="5511800" y="1985772"/>
+            <a:ext cx="2108200" cy="127000"/>
+          </a:xfrm>
+          <a:prstGeom prst="rect">
+            <a:avLst/>
+          </a:prstGeom>
+          <a:noFill/>
+        </p:spPr>
+        <p:txBody>
+          <a:bodyPr wrap="square" lIns="0" rIns="0" tIns="0" bIns="0" anchor="t">
+            <a:spAutoFit/>
+          </a:bodyPr>
+          <a:lstStyle/>
+          <a:p>
+            <a:pPr algn="ctr">
+              <a:lnSpc>
+                <a:spcPts val="840"/>
+              </a:lnSpc>
+              <a:spcAft>
+                <a:spcPts val="0"/>
+              </a:spcAft>
+            </a:pPr>
+            <a:r>
+              <a:rPr sz="690" b="0" i="0">
+                <a:solidFill>
+                  <a:srgbClr val="FFFFFF"/>
+                </a:solidFill>
+                <a:latin typeface="Ubuntu Mono"/>
+                <a:ea typeface="Ubuntu Mono"/>
+                <a:cs typeface="Ubuntu Mono"/>
+                <a:sym typeface="Ubuntu Mono"/>
+              </a:rPr>
+              <a:t/>
+            </a:r>
+          </a:p>
+        </p:txBody>
+      </p:sp>
+      <p:sp>
+        <p:nvSpPr>
+          <p:cNvPr id="20" name="Rectangle 19"/>
+          <p:cNvSpPr/>
+          <p:nvPr/>
+        </p:nvSpPr>
+        <p:spPr>
+          <a:xfrm>
+            <a:off x="6515100" y="2133600"/>
+            <a:ext cx="101600" cy="177800"/>
+          </a:xfrm>
+          <a:prstGeom prst="rect">
+            <a:avLst/>
+          </a:prstGeom>
+          <a:solidFill>
+            <a:srgbClr val="2BAEF6"/>
+          </a:solidFill>
+          <a:ln>
+            <a:noFill/>
+          </a:ln>
+        </p:spPr>
+        <p:txBody>
+          <a:bodyPr rtlCol="0" anchor="ctr"/>
+          <a:lstStyle/>
+          <a:p>
+            <a:pPr algn="ctr"/>
+          </a:p>
+        </p:txBody>
+      </p:sp>
+      <p:sp>
+        <p:nvSpPr>
+          <p:cNvPr id="21" name="TextBox 20"/>
+          <p:cNvSpPr txBox="1"/>
+          <p:nvPr/>
+        </p:nvSpPr>
+        <p:spPr>
+          <a:xfrm>
+            <a:off x="5435600" y="2489200"/>
+            <a:ext cx="2260600" cy="127000"/>
+          </a:xfrm>
+          <a:prstGeom prst="rect">
+            <a:avLst/>
+          </a:prstGeom>
+          <a:noFill/>
+        </p:spPr>
+        <p:txBody>
+          <a:bodyPr wrap="square" lIns="0" rIns="0" tIns="0" bIns="0" anchor="t">
+            <a:spAutoFit/>
+          </a:bodyPr>
+          <a:lstStyle/>
+          <a:p>
+            <a:pPr algn="l">
+              <a:lnSpc>
+                <a:spcPts val="1050"/>
+              </a:lnSpc>
+              <a:spcAft>
+                <a:spcPts val="400"/>
+              </a:spcAft>
+            </a:pPr>
+            <a:r>
+              <a:rPr sz="880" b="1" i="0">
+                <a:solidFill>
+                  <a:srgbClr val="194E9A"/>
+                </a:solidFill>
+                <a:latin typeface="Ubuntu Mono"/>
+                <a:ea typeface="Ubuntu Mono"/>
+                <a:cs typeface="Ubuntu Mono"/>
+                <a:sym typeface="Ubuntu Mono"/>
+              </a:rPr>
+              <a:t>NEW OWNERS</a:t>
+            </a:r>
+          </a:p>
+          <a:p>
+            <a:pPr algn="l">
+              <a:lnSpc>
+                <a:spcPts val="1050"/>
+              </a:lnSpc>
+              <a:spcAft>
+                <a:spcPts val="400"/>
+              </a:spcAft>
+            </a:pPr>
+            <a:r>
+              <a:rPr sz="760" b="0" i="0">
+                <a:solidFill>
+                  <a:srgbClr val="0B1B2E"/>
+                </a:solidFill>
+                <a:latin typeface="Ubuntu Mono"/>
+                <a:ea typeface="Ubuntu Mono"/>
+                <a:cs typeface="Ubuntu Mono"/>
+                <a:sym typeface="Ubuntu Mono"/>
+              </a:rPr>
+              <a:t>Fabien Jacquot and Alexis Estines take over the company.</a:t>
+            </a:r>
+          </a:p>
+        </p:txBody>
+      </p:sp>
+      <p:sp>
+        <p:nvSpPr>
+          <p:cNvPr id="22" name="Rectangle 21"/>
+          <p:cNvSpPr/>
+          <p:nvPr/>
+        </p:nvSpPr>
+        <p:spPr>
+          <a:xfrm>
+            <a:off x="7924800" y="1524000"/>
+            <a:ext cx="2260600" cy="584200"/>
+          </a:xfrm>
+          <a:prstGeom prst="rect">
+            <a:avLst/>
+          </a:prstGeom>
+          <a:solidFill>
+            <a:srgbClr val="194E9A"/>
+          </a:solidFill>
+          <a:ln>
+            <a:noFill/>
+          </a:ln>
+        </p:spPr>
+        <p:txBody>
+          <a:bodyPr rtlCol="0" anchor="ctr"/>
+          <a:lstStyle/>
+          <a:p>
+            <a:pPr algn="ctr"/>
+          </a:p>
+        </p:txBody>
+      </p:sp>
+      <p:sp>
+        <p:nvSpPr>
+          <p:cNvPr id="23" name="TextBox 22"/>
+          <p:cNvSpPr txBox="1"/>
+          <p:nvPr/>
+        </p:nvSpPr>
+        <p:spPr>
+          <a:xfrm>
+            <a:off x="7924800" y="1617472"/>
+            <a:ext cx="2260600" cy="127000"/>
+          </a:xfrm>
+          <a:prstGeom prst="rect">
+            <a:avLst/>
+          </a:prstGeom>
+          <a:noFill/>
+        </p:spPr>
+        <p:txBody>
+          <a:bodyPr wrap="square" lIns="0" rIns="0" tIns="0" bIns="0" anchor="t">
+            <a:spAutoFit/>
+          </a:bodyPr>
+          <a:lstStyle/>
+          <a:p>
+            <a:pPr algn="ctr">
+              <a:lnSpc>
+                <a:spcPts val="2700"/>
+              </a:lnSpc>
+              <a:spcAft>
+                <a:spcPts val="0"/>
+              </a:spcAft>
+            </a:pPr>
+            <a:r>
+              <a:rPr sz="2400" b="1" i="0">
+                <a:solidFill>
+                  <a:srgbClr val="FFFFFF"/>
+                </a:solidFill>
+                <a:latin typeface="Ubuntu Mono"/>
+                <a:ea typeface="Ubuntu Mono"/>
+                <a:cs typeface="Ubuntu Mono"/>
+                <a:sym typeface="Ubuntu Mono"/>
+              </a:rPr>
+              <a:t>2025</a:t>
+            </a:r>
+          </a:p>
+        </p:txBody>
+      </p:sp>
+      <p:sp>
+        <p:nvSpPr>
+          <p:cNvPr id="24" name="TextBox 23"/>
+          <p:cNvSpPr txBox="1"/>
+          <p:nvPr/>
+        </p:nvSpPr>
+        <p:spPr>
+          <a:xfrm>
+            <a:off x="8001000" y="1985772"/>
+            <a:ext cx="2108200" cy="127000"/>
+          </a:xfrm>
+          <a:prstGeom prst="rect">
+            <a:avLst/>
+          </a:prstGeom>
+          <a:noFill/>
+        </p:spPr>
+        <p:txBody>
+          <a:bodyPr wrap="square" lIns="0" rIns="0" tIns="0" bIns="0" anchor="t">
+            <a:spAutoFit/>
+          </a:bodyPr>
+          <a:lstStyle/>
+          <a:p>
+            <a:pPr algn="ctr">
+              <a:lnSpc>
+                <a:spcPts val="840"/>
+              </a:lnSpc>
+              <a:spcAft>
+                <a:spcPts val="0"/>
+              </a:spcAft>
+            </a:pPr>
+            <a:r>
+              <a:rPr sz="690" b="0" i="0">
+                <a:solidFill>
+                  <a:srgbClr val="FFFFFF"/>
+                </a:solidFill>
+                <a:latin typeface="Ubuntu Mono"/>
+                <a:ea typeface="Ubuntu Mono"/>
+                <a:cs typeface="Ubuntu Mono"/>
+                <a:sym typeface="Ubuntu Mono"/>
+              </a:rPr>
+              <a:t/>
+            </a:r>
+          </a:p>
+        </p:txBody>
+      </p:sp>
+      <p:sp>
+        <p:nvSpPr>
+          <p:cNvPr id="25" name="Rectangle 24"/>
+          <p:cNvSpPr/>
+          <p:nvPr/>
+        </p:nvSpPr>
+        <p:spPr>
+          <a:xfrm>
+            <a:off x="9004300" y="2133600"/>
+            <a:ext cx="101600" cy="177800"/>
+          </a:xfrm>
+          <a:prstGeom prst="rect">
+            <a:avLst/>
+          </a:prstGeom>
+          <a:solidFill>
+            <a:srgbClr val="194E9A"/>
+          </a:solidFill>
+          <a:ln>
+            <a:noFill/>
+          </a:ln>
+        </p:spPr>
+        <p:txBody>
+          <a:bodyPr rtlCol="0" anchor="ctr"/>
+          <a:lstStyle/>
+          <a:p>
+            <a:pPr algn="ctr"/>
+          </a:p>
+        </p:txBody>
+      </p:sp>
+      <p:sp>
+        <p:nvSpPr>
+          <p:cNvPr id="26" name="TextBox 25"/>
+          <p:cNvSpPr txBox="1"/>
+          <p:nvPr/>
+        </p:nvSpPr>
+        <p:spPr>
+          <a:xfrm>
+            <a:off x="7924800" y="2489200"/>
+            <a:ext cx="2260600" cy="127000"/>
+          </a:xfrm>
+          <a:prstGeom prst="rect">
+            <a:avLst/>
+          </a:prstGeom>
+          <a:noFill/>
+        </p:spPr>
+        <p:txBody>
+          <a:bodyPr wrap="square" lIns="0" rIns="0" tIns="0" bIns="0" anchor="t">
+            <a:spAutoFit/>
+          </a:bodyPr>
+          <a:lstStyle/>
+          <a:p>
+            <a:pPr algn="l">
+              <a:lnSpc>
+                <a:spcPts val="1050"/>
+              </a:lnSpc>
+              <a:spcAft>
+                <a:spcPts val="400"/>
+              </a:spcAft>
+            </a:pPr>
+            <a:r>
+              <a:rPr sz="880" b="1" i="0">
+                <a:solidFill>
+                  <a:srgbClr val="194E9A"/>
+                </a:solidFill>
+                <a:latin typeface="Ubuntu Mono"/>
+                <a:ea typeface="Ubuntu Mono"/>
+                <a:cs typeface="Ubuntu Mono"/>
+                <a:sym typeface="Ubuntu Mono"/>
+              </a:rPr>
+              <a:t>ENEDRIL</a:t>
+            </a:r>
+          </a:p>
+          <a:p>
+            <a:pPr algn="l">
+              <a:lnSpc>
+                <a:spcPts val="1050"/>
+              </a:lnSpc>
+              <a:spcAft>
+                <a:spcPts val="400"/>
+              </a:spcAft>
+            </a:pPr>
+            <a:r>
+              <a:rPr sz="760" b="0" i="0">
+                <a:solidFill>
+                  <a:srgbClr val="0B1B2E"/>
+                </a:solidFill>
+                <a:latin typeface="Ubuntu Mono"/>
+                <a:ea typeface="Ubuntu Mono"/>
+                <a:cs typeface="Ubuntu Mono"/>
+                <a:sym typeface="Ubuntu Mono"/>
+              </a:rPr>
+              <a:t>Rebranding: Mustang Oil Services becomes Enedril, Fishing and Drilling Solutions.</a:t>
+            </a:r>
+          </a:p>
+        </p:txBody>
+      </p:sp>
+      <p:sp>
+        <p:nvSpPr>
+          <p:cNvPr id="27" name="Rectangle 26"/>
+          <p:cNvSpPr/>
+          <p:nvPr/>
+        </p:nvSpPr>
+        <p:spPr>
+          <a:xfrm>
+            <a:off x="457200" y="3683000"/>
+            <a:ext cx="4800600" cy="2159000"/>
+          </a:xfrm>
+          <a:prstGeom prst="rect">
+            <a:avLst/>
+          </a:prstGeom>
+          <a:solidFill>
+            <a:srgbClr val="194E9A"/>
+          </a:solidFill>
+          <a:ln>
+            <a:noFill/>
+          </a:ln>
+        </p:spPr>
+        <p:txBody>
+          <a:bodyPr rtlCol="0" anchor="ctr"/>
+          <a:lstStyle/>
+          <a:p>
+            <a:pPr algn="ctr"/>
+          </a:p>
+        </p:txBody>
+      </p:sp>
+      <p:sp>
+        <p:nvSpPr>
+          <p:cNvPr id="28" name="TextBox 27"/>
+          <p:cNvSpPr txBox="1"/>
+          <p:nvPr/>
+        </p:nvSpPr>
+        <p:spPr>
+          <a:xfrm>
+            <a:off x="660400" y="3683000"/>
+            <a:ext cx="4394200" cy="2159000"/>
+          </a:xfrm>
+          <a:prstGeom prst="rect">
+            <a:avLst/>
+          </a:prstGeom>
+          <a:noFill/>
+        </p:spPr>
+        <p:txBody>
+          <a:bodyPr wrap="square" lIns="0" rIns="0" tIns="0" bIns="0" anchor="ctr">
+            <a:spAutoFit/>
+          </a:bodyPr>
+          <a:lstStyle/>
+          <a:p>
+            <a:pPr algn="l">
+              <a:lnSpc>
+                <a:spcPts val="1400"/>
+              </a:lnSpc>
+              <a:spcAft>
+                <a:spcPts val="600"/>
+              </a:spcAft>
+            </a:pPr>
+            <a:r>
+              <a:rPr sz="880" b="1" i="0">
+                <a:solidFill>
+                  <a:srgbClr val="1CB2FE"/>
+                </a:solidFill>
+                <a:latin typeface="Ubuntu Mono"/>
+                <a:ea typeface="Ubuntu Mono"/>
+                <a:cs typeface="Ubuntu Mono"/>
+                <a:sym typeface="Ubuntu Mono"/>
+              </a:rPr>
+              <a:t>CONTINUITY</a:t>
+            </a:r>
+          </a:p>
+          <a:p>
+            <a:pPr algn="l">
+              <a:lnSpc>
+                <a:spcPts val="1400"/>
+              </a:lnSpc>
+              <a:spcAft>
+                <a:spcPts val="600"/>
+              </a:spcAft>
+            </a:pPr>
+            <a:r>
+              <a:rPr sz="1050" b="1" i="0">
+                <a:solidFill>
+                  <a:srgbClr val="FFFFFF"/>
+                </a:solidFill>
+                <a:latin typeface="Ubuntu Mono"/>
+                <a:ea typeface="Ubuntu Mono"/>
+                <a:cs typeface="Ubuntu Mono"/>
+                <a:sym typeface="Ubuntu Mono"/>
+              </a:rPr>
+              <a:t>Since the takeover in 2022, the activities continue as before: fishing, workover, plug and abandonment and directional drilling, with the same commitment to our clients.</a:t>
+            </a:r>
+          </a:p>
+        </p:txBody>
+      </p:sp>
+      <p:sp>
+        <p:nvSpPr>
+          <p:cNvPr id="29" name="Rectangle 28"/>
+          <p:cNvSpPr/>
+          <p:nvPr/>
+        </p:nvSpPr>
+        <p:spPr>
+          <a:xfrm>
+            <a:off x="5435600" y="3683000"/>
+            <a:ext cx="4800600" cy="2159000"/>
+          </a:xfrm>
+          <a:prstGeom prst="rect">
+            <a:avLst/>
+          </a:prstGeom>
+          <a:solidFill>
+            <a:srgbClr val="0F7FCB"/>
+          </a:solidFill>
+          <a:ln>
+            <a:noFill/>
+          </a:ln>
+        </p:spPr>
+        <p:txBody>
+          <a:bodyPr rtlCol="0" anchor="ctr"/>
+          <a:lstStyle/>
+          <a:p>
+            <a:pPr algn="ctr"/>
+          </a:p>
+        </p:txBody>
+      </p:sp>
+      <p:sp>
+        <p:nvSpPr>
+          <p:cNvPr id="30" name="TextBox 29"/>
+          <p:cNvSpPr txBox="1"/>
+          <p:nvPr/>
+        </p:nvSpPr>
+        <p:spPr>
+          <a:xfrm>
+            <a:off x="5638800" y="3683000"/>
+            <a:ext cx="4394200" cy="2159000"/>
+          </a:xfrm>
+          <a:prstGeom prst="rect">
+            <a:avLst/>
+          </a:prstGeom>
+          <a:noFill/>
+        </p:spPr>
+        <p:txBody>
+          <a:bodyPr wrap="square" lIns="0" rIns="0" tIns="0" bIns="0" anchor="ctr">
+            <a:spAutoFit/>
+          </a:bodyPr>
+          <a:lstStyle/>
+          <a:p>
+            <a:pPr algn="l">
+              <a:lnSpc>
+                <a:spcPts val="1400"/>
+              </a:lnSpc>
+              <a:spcAft>
+                <a:spcPts val="600"/>
+              </a:spcAft>
+            </a:pPr>
+            <a:r>
+              <a:rPr sz="880" b="1" i="0">
+                <a:solidFill>
+                  <a:srgbClr val="FFFFFF"/>
+                </a:solidFill>
+                <a:latin typeface="Ubuntu Mono"/>
+                <a:ea typeface="Ubuntu Mono"/>
+                <a:cs typeface="Ubuntu Mono"/>
+                <a:sym typeface="Ubuntu Mono"/>
+              </a:rPr>
+              <a:t>A NEW DYNAMIC</a:t>
+            </a:r>
+          </a:p>
+          <a:p>
+            <a:pPr algn="l">
+              <a:lnSpc>
+                <a:spcPts val="1400"/>
+              </a:lnSpc>
+              <a:spcAft>
+                <a:spcPts val="600"/>
+              </a:spcAft>
+            </a:pPr>
+            <a:r>
+              <a:rPr sz="1050" b="1" i="0">
+                <a:solidFill>
+                  <a:srgbClr val="FFFFFF"/>
+                </a:solidFill>
+                <a:latin typeface="Ubuntu Mono"/>
+                <a:ea typeface="Ubuntu Mono"/>
+                <a:cs typeface="Ubuntu Mono"/>
+                <a:sym typeface="Ubuntu Mono"/>
+              </a:rPr>
+              <a:t>Fabien and Alexis want to give the company a new momentum, with, among other steps, the 2025 rebranding that gave birth to Enedril.</a:t>
+            </a:r>
+          </a:p>
+        </p:txBody>
+      </p:sp>
+      <p:sp>
+        <p:nvSpPr>
+          <p:cNvPr id="31" name="Rectangle 30"/>
+          <p:cNvSpPr/>
+          <p:nvPr/>
+        </p:nvSpPr>
+        <p:spPr>
+          <a:xfrm>
+            <a:off x="457200" y="6146800"/>
+            <a:ext cx="9779000" cy="635000"/>
+          </a:xfrm>
+          <a:prstGeom prst="rect">
+            <a:avLst/>
+          </a:prstGeom>
+          <a:solidFill>
+            <a:srgbClr val="EAF4FC"/>
+          </a:solidFill>
+          <a:ln>
+            <a:noFill/>
+          </a:ln>
+        </p:spPr>
+        <p:txBody>
+          <a:bodyPr rtlCol="0" anchor="ctr"/>
+          <a:lstStyle/>
+          <a:p>
+            <a:pPr algn="ctr"/>
+          </a:p>
+        </p:txBody>
+      </p:sp>
+      <p:sp>
+        <p:nvSpPr>
+          <p:cNvPr id="32" name="TextBox 31"/>
+          <p:cNvSpPr txBox="1"/>
+          <p:nvPr/>
+        </p:nvSpPr>
+        <p:spPr>
+          <a:xfrm>
+            <a:off x="635000" y="6146800"/>
+            <a:ext cx="9448800" cy="635000"/>
+          </a:xfrm>
+          <a:prstGeom prst="rect">
+            <a:avLst/>
+          </a:prstGeom>
+          <a:noFill/>
+        </p:spPr>
+        <p:txBody>
+          <a:bodyPr wrap="square" lIns="0" rIns="0" tIns="0" bIns="0" anchor="ctr">
+            <a:spAutoFit/>
+          </a:bodyPr>
+          <a:lstStyle/>
+          <a:p>
+            <a:pPr algn="l">
+              <a:lnSpc>
+                <a:spcPts val="1050"/>
+              </a:lnSpc>
+              <a:spcAft>
+                <a:spcPts val="0"/>
+              </a:spcAft>
+            </a:pPr>
+            <a:r>
+              <a:rPr sz="800" b="1" i="0">
+                <a:solidFill>
+                  <a:srgbClr val="194E9A"/>
+                </a:solidFill>
+                <a:latin typeface="Ubuntu Mono"/>
+                <a:ea typeface="Ubuntu Mono"/>
+                <a:cs typeface="Ubuntu Mono"/>
+                <a:sym typeface="Ubuntu Mono"/>
+              </a:rPr>
+              <a:t>TODAY: </a:t>
+            </a:r>
+            <a:r>
+              <a:rPr sz="800" b="0" i="0">
+                <a:solidFill>
+                  <a:srgbClr val="0B1B2E"/>
+                </a:solidFill>
+                <a:latin typeface="Ubuntu Mono"/>
+                <a:ea typeface="Ubuntu Mono"/>
+                <a:cs typeface="Ubuntu Mono"/>
+                <a:sym typeface="Ubuntu Mono"/>
+              </a:rPr>
+              <a:t>independent French company based in Lons, near Pau, specialised in directional drilling, fishing and well intervention for geothermal, oil &amp; gas and underground gas storage.</a:t>
+            </a:r>
+          </a:p>
+        </p:txBody>
+      </p:sp>
+      <p:sp>
+        <p:nvSpPr>
+          <p:cNvPr id="33" name="Rectangle 32"/>
+          <p:cNvSpPr/>
+          <p:nvPr/>
+        </p:nvSpPr>
+        <p:spPr>
+          <a:xfrm>
+            <a:off x="457200" y="7213600"/>
+            <a:ext cx="9779000" cy="10160"/>
+          </a:xfrm>
+          <a:prstGeom prst="rect">
+            <a:avLst/>
+          </a:prstGeom>
+          <a:solidFill>
+            <a:srgbClr val="B9CCE0"/>
+          </a:solidFill>
+          <a:ln>
+            <a:noFill/>
+          </a:ln>
+        </p:spPr>
+        <p:txBody>
+          <a:bodyPr rtlCol="0" anchor="ctr"/>
+          <a:lstStyle/>
+          <a:p>
+            <a:pPr algn="ctr"/>
+          </a:p>
+        </p:txBody>
+      </p:sp>
+      <p:sp>
+        <p:nvSpPr>
+          <p:cNvPr id="34" name="TextBox 33"/>
+          <p:cNvSpPr txBox="1"/>
+          <p:nvPr/>
+        </p:nvSpPr>
+        <p:spPr>
+          <a:xfrm>
+            <a:off x="457200" y="7289800"/>
+            <a:ext cx="7620000" cy="127000"/>
+          </a:xfrm>
+          <a:prstGeom prst="rect">
+            <a:avLst/>
+          </a:prstGeom>
+          <a:noFill/>
+        </p:spPr>
+        <p:txBody>
+          <a:bodyPr wrap="square" lIns="0" rIns="0" tIns="0" bIns="0" anchor="t">
+            <a:spAutoFit/>
+          </a:bodyPr>
+          <a:lstStyle/>
+          <a:p>
+            <a:pPr algn="l">
+              <a:spcAft>
+                <a:spcPts val="0"/>
+              </a:spcAft>
+            </a:pPr>
+            <a:r>
+              <a:rPr sz="640" b="0" i="0">
+                <a:solidFill>
+                  <a:srgbClr val="5A6B7F"/>
+                </a:solidFill>
+                <a:latin typeface="Ubuntu Mono"/>
+                <a:ea typeface="Ubuntu Mono"/>
+                <a:cs typeface="Ubuntu Mono"/>
+                <a:sym typeface="Ubuntu Mono"/>
+              </a:rPr>
+              <a:t>Enedril · Fishing and Drilling Solutions · 3 avenue des lacs, 64140 Lons (France) · info@enedril.fr · +33 (0)5 59 04 50 45</a:t>
+            </a:r>
+          </a:p>
+        </p:txBody>
+      </p:sp>
+      <p:sp>
+        <p:nvSpPr>
+          <p:cNvPr id="35" name="TextBox 34"/>
+          <p:cNvSpPr txBox="1"/>
+          <p:nvPr/>
+        </p:nvSpPr>
+        <p:spPr>
+          <a:xfrm>
+            <a:off x="9740900" y="7289800"/>
+            <a:ext cx="495300" cy="127000"/>
+          </a:xfrm>
+          <a:prstGeom prst="rect">
+            <a:avLst/>
+          </a:prstGeom>
+          <a:noFill/>
+        </p:spPr>
+        <p:txBody>
+          <a:bodyPr wrap="square" lIns="0" rIns="0" tIns="0" bIns="0" anchor="t">
+            <a:spAutoFit/>
+          </a:bodyPr>
+          <a:lstStyle/>
+          <a:p>
+            <a:pPr algn="r">
+              <a:spcAft>
+                <a:spcPts val="0"/>
+              </a:spcAft>
+            </a:pPr>
+            <a:r>
+              <a:rPr sz="800" b="0" i="0">
+                <a:solidFill>
+                  <a:srgbClr val="194E9A"/>
+                </a:solidFill>
+                <a:latin typeface="Ubuntu Mono"/>
+                <a:ea typeface="Ubuntu Mono"/>
+                <a:cs typeface="Ubuntu Mono"/>
+                <a:sym typeface="Ubuntu Mono"/>
+              </a:rPr>
+              <a:t>3</a:t>
+            </a:r>
+          </a:p>
+        </p:txBody>
+      </p:sp>
+    </p:spTree>
+  </p:cSld>
+  <p:clrMapOvr>
+    <a:masterClrMapping/>
+  </p:clrMapOvr>
+</p:sld>
+</file>
+
+<file path=ppt/slides/slide4.xml><?xml version="1.0" encoding="utf-8"?>
 <p:sld xmlns:a="http://schemas.openxmlformats.org/drawingml/2006/main" xmlns:p="http://schemas.openxmlformats.org/presentationml/2006/main" xmlns:r="http://schemas.openxmlformats.org/officeDocument/2006/relationships">
   <p:cSld>
     <p:spTree>
@@ -8466,7 +9908,7 @@
                 <a:cs typeface="Ubuntu Mono"/>
                 <a:sym typeface="Ubuntu Mono"/>
               </a:rPr>
-              <a:t>3</a:t>
+              <a:t>4</a:t>
             </a:r>
           </a:p>
         </p:txBody>
@@ -8479,7 +9921,7 @@
 </p:sld>
 </file>
 
-<file path=ppt/slides/slide4.xml><?xml version="1.0" encoding="utf-8"?>
+<file path=ppt/slides/slide5.xml><?xml version="1.0" encoding="utf-8"?>
 <p:sld xmlns:a="http://schemas.openxmlformats.org/drawingml/2006/main" xmlns:p="http://schemas.openxmlformats.org/presentationml/2006/main" xmlns:r="http://schemas.openxmlformats.org/officeDocument/2006/relationships">
   <p:cSld>
     <p:spTree>
@@ -10345,7 +11787,7 @@
                 <a:cs typeface="Ubuntu Mono"/>
                 <a:sym typeface="Ubuntu Mono"/>
               </a:rPr>
-              <a:t>4</a:t>
+              <a:t>5</a:t>
             </a:r>
           </a:p>
         </p:txBody>
@@ -10358,7 +11800,7 @@
 </p:sld>
 </file>
 
-<file path=ppt/slides/slide5.xml><?xml version="1.0" encoding="utf-8"?>
+<file path=ppt/slides/slide6.xml><?xml version="1.0" encoding="utf-8"?>
 <p:sld xmlns:a="http://schemas.openxmlformats.org/drawingml/2006/main" xmlns:p="http://schemas.openxmlformats.org/presentationml/2006/main" xmlns:r="http://schemas.openxmlformats.org/officeDocument/2006/relationships">
   <p:cSld>
     <p:spTree>
@@ -15071,7 +16513,7 @@
                 <a:cs typeface="Ubuntu Mono"/>
                 <a:sym typeface="Ubuntu Mono"/>
               </a:rPr>
-              <a:t>5</a:t>
+              <a:t>6</a:t>
             </a:r>
           </a:p>
         </p:txBody>
@@ -15084,7 +16526,7 @@
 </p:sld>
 </file>
 
-<file path=ppt/slides/slide6.xml><?xml version="1.0" encoding="utf-8"?>
+<file path=ppt/slides/slide7.xml><?xml version="1.0" encoding="utf-8"?>
 <p:sld xmlns:a="http://schemas.openxmlformats.org/drawingml/2006/main" xmlns:p="http://schemas.openxmlformats.org/presentationml/2006/main" xmlns:r="http://schemas.openxmlformats.org/officeDocument/2006/relationships">
   <p:cSld>
     <p:spTree>

</xml_diff>